<commit_message>
feat: final Pitchathon submission gate — evaluation suite, pilot docs, deck/one-pager updates, verification
</commit_message>
<xml_diff>
--- a/submission/final-2026-10-18/Klarrow_One_Pager.pptx
+++ b/submission/final-2026-10-18/Klarrow_One_Pager.pptx
@@ -3963,7 +3963,7 @@
                 </a:solidFill>
                 <a:latin typeface="Segoe UI"/>
               </a:rPr>
-              <a:t>-  Uses local Meta Llama 3.2 3B to propose candidate facts; deterministic code handles structured parsing and traversal.</a:t>
+              <a:t>-  Uses local Meta Llama 3.2 3B to propose candidate facts; deterministic code handles structured parsing and traversal; a three-scenario evaluation suite passes all locked checks in deterministic mode.</a:t>
             </a:r>
           </a:p>
         </p:txBody>
@@ -4125,7 +4125,7 @@
                 </a:solidFill>
                 <a:latin typeface="Segoe UI"/>
               </a:rPr>
-              <a:t>Not a recall decision system. Not certified. Not production-ready. One authored scenario; accuracy, time savings and customer demand remain unmeasured.</a:t>
+              <a:t>Not a recall decision system. Not certified. Not production-ready. The Run 4 demo is one authored scenario; accuracy, time savings and customer demand remain unmeasured.</a:t>
             </a:r>
           </a:p>
         </p:txBody>

</xml_diff>